<commit_message>
Lecture 6: Norm slides woven through the deck and flagged AI-generated; Norm game gains Skinner, AI-feedback, truth-in-context and norm/deviance notes
</commit_message>
<xml_diff>
--- a/courses/479-fall-2026/479-lecture-4.pptx
+++ b/courses/479-fall-2026/479-lecture-4.pptx
@@ -42,6 +42,9 @@
     <p:sldId id="290" r:id="rId42"/>
     <p:sldId id="291" r:id="rId43"/>
     <p:sldId id="292" r:id="rId44"/>
+    <p:sldId id="293" r:id="rId45"/>
+    <p:sldId id="294" r:id="rId46"/>
+    <p:sldId id="295" r:id="rId47"/>
   </p:sldIdLst>
   <p:sldSz cx="12191695" cy="6858000" type="screen4x3"/>
   <p:notesSz cx="6858000" cy="9144000"/>
@@ -544,13 +547,19 @@
           <a:p/>
           <a:p>
             <a:r>
-              <a:t>What I propose this week is that we examine three key papers that all treat the concept of attention in a specific way. I won’t be doing too much here to relate this concept to Hegel’s unfolding architecture in Phenomenology of Spirit - we’ll instead turn to that in the weeks ahead. But you may want to think how different meanings of attention might be situated with respect to both concepts of experience and recognition we’ve covered to date.</a:t>
+              <a:t>What I propose this week is that we examine four key papers that all treat the concept of attention in a specific way. I won’t be doing too much here to relate this concept to Hegel’s unfolding architecture in Phenomenology of Spirit - we’ll instead turn to that in the weeks ahead. But you may want to think how different meanings of attention might be situated with respect to both concepts of experience and recognition we’ve covered to date.</a:t>
             </a:r>
           </a:p>
           <a:p/>
           <a:p>
             <a:r>
               <a:t>I’ll start by looking at the Petersen &amp; Posner paper, The Attention System of the Human Brain: 20 Years After, then the Vaswani et al’s Attention is All You Need paper, and then finally Terranova’s critique of the Attention Economy. In each case we’ll provide a short summary, and connect the argument to the wider lecture and course content - then provide time for discussion.</a:t>
+            </a:r>
+          </a:p>
+          <a:p/>
+          <a:p>
+            <a:r>
+              <a:t>Note that our discussions of these papers will be very high level - just enough to get some intuition of similarities and differences.</a:t>
             </a:r>
           </a:p>
         </p:txBody>
@@ -11761,7 +11770,7 @@
         <p:spPr>
           <a:xfrm>
             <a:off x="612648" y="1664207"/>
-            <a:ext cx="10972800" cy="1615440"/>
+            <a:ext cx="10972800" cy="2057400"/>
           </a:xfrm>
           <a:prstGeom prst="rect">
             <a:avLst/>
@@ -11820,7 +11829,32 @@
                 </a:solidFill>
                 <a:latin typeface="Iowan Old Style"/>
               </a:rPr>
-              <a:t>Some comments later on relationship to Hegel - but is there a relationship between alerting / orienting / executing and sense certainty / perception / understanding?</a:t>
+              <a:t>Some comments later on relationship to Hegel - but is there a relationship between alerting / orienting / executing (Petersen and Posner, 2012) and sense certainty / perception / understanding (Hegel, 1807)?</a:t>
+            </a:r>
+          </a:p>
+          <a:p>
+            <a:pPr marL="274320" indent="-219456">
+              <a:lnSpc>
+                <a:spcPct val="108000"/>
+              </a:lnSpc>
+              <a:spcAft>
+                <a:spcPts val="600"/>
+              </a:spcAft>
+              <a:buClr>
+                <a:srgbClr val="F0C9A0"/>
+              </a:buClr>
+              <a:buSzPct val="90000"/>
+              <a:buFont typeface="Arial"/>
+              <a:buChar char="•"/>
+            </a:pPr>
+            <a:r>
+              <a:rPr sz="2400" b="0" i="0">
+                <a:solidFill>
+                  <a:srgbClr val="ECE7F0"/>
+                </a:solidFill>
+                <a:latin typeface="Iowan Old Style"/>
+              </a:rPr>
+              <a:t>Terranova (attention economy), Hansen (cognitive lock-in)</a:t>
             </a:r>
           </a:p>
         </p:txBody>
@@ -12719,7 +12753,7 @@
                 </a:solidFill>
                 <a:latin typeface="Iowan Old Style"/>
               </a:rPr>
-              <a:t>Make Content, Get Attention… Profit?</a:t>
+              <a:t>Similarities and differences</a:t>
             </a:r>
           </a:p>
         </p:txBody>
@@ -12768,30 +12802,154 @@
           </a:p>
         </p:txBody>
       </p:sp>
-      <p:pic>
-        <p:nvPicPr>
-          <p:cNvPr id="4" name="Picture 3" descr="image.png"/>
-          <p:cNvPicPr>
-            <a:picLocks noChangeAspect="1"/>
-          </p:cNvPicPr>
+      <p:sp>
+        <p:nvSpPr>
+          <p:cNvPr id="4" name="TextBox 3"/>
+          <p:cNvSpPr txBox="1"/>
           <p:nvPr/>
-        </p:nvPicPr>
-        <p:blipFill>
-          <a:blip r:embed="rId2"/>
-          <a:stretch>
-            <a:fillRect/>
-          </a:stretch>
-        </p:blipFill>
-        <p:spPr>
-          <a:xfrm>
-            <a:off x="3704691" y="1664207"/>
-            <a:ext cx="4782312" cy="4782312"/>
+        </p:nvSpPr>
+        <p:spPr>
+          <a:xfrm>
+            <a:off x="612648" y="1664207"/>
+            <a:ext cx="10972800" cy="3581399"/>
           </a:xfrm>
           <a:prstGeom prst="rect">
             <a:avLst/>
           </a:prstGeom>
-        </p:spPr>
-      </p:pic>
+          <a:noFill/>
+        </p:spPr>
+        <p:txBody>
+          <a:bodyPr wrap="square" anchor="t" lIns="0" rIns="0" tIns="0" bIns="0">
+            <a:noAutofit/>
+          </a:bodyPr>
+          <a:lstStyle/>
+          <a:p>
+            <a:pPr marL="274320" indent="-219456">
+              <a:lnSpc>
+                <a:spcPct val="108000"/>
+              </a:lnSpc>
+              <a:spcAft>
+                <a:spcPts val="600"/>
+              </a:spcAft>
+              <a:buClr>
+                <a:srgbClr val="F0C9A0"/>
+              </a:buClr>
+              <a:buSzPct val="90000"/>
+              <a:buFont typeface="Arial"/>
+              <a:buChar char="•"/>
+            </a:pPr>
+            <a:r>
+              <a:rPr sz="2400" b="0" i="0">
+                <a:solidFill>
+                  <a:srgbClr val="ECE7F0"/>
+                </a:solidFill>
+                <a:latin typeface="Iowan Old Style"/>
+              </a:rPr>
+              <a:t>Curious that two very different mechanisms use the same term “attention”</a:t>
+            </a:r>
+          </a:p>
+          <a:p>
+            <a:pPr marL="274320" indent="-219456">
+              <a:lnSpc>
+                <a:spcPct val="108000"/>
+              </a:lnSpc>
+              <a:spcAft>
+                <a:spcPts val="600"/>
+              </a:spcAft>
+              <a:buClr>
+                <a:srgbClr val="F0C9A0"/>
+              </a:buClr>
+              <a:buSzPct val="90000"/>
+              <a:buFont typeface="Arial"/>
+              <a:buChar char="•"/>
+            </a:pPr>
+            <a:r>
+              <a:rPr sz="2400" b="0" i="0">
+                <a:solidFill>
+                  <a:srgbClr val="ECE7F0"/>
+                </a:solidFill>
+                <a:latin typeface="Iowan Old Style"/>
+              </a:rPr>
+              <a:t>Really it is metaphorical - substantial differences in what these systems do, and at what scale:</a:t>
+            </a:r>
+          </a:p>
+          <a:p>
+            <a:pPr marL="548640" indent="-219456">
+              <a:lnSpc>
+                <a:spcPct val="108000"/>
+              </a:lnSpc>
+              <a:spcAft>
+                <a:spcPts val="600"/>
+              </a:spcAft>
+              <a:buClr>
+                <a:srgbClr val="F0C9A0"/>
+              </a:buClr>
+              <a:buSzPct val="90000"/>
+              <a:buFont typeface="Arial"/>
+              <a:buChar char="–"/>
+            </a:pPr>
+            <a:r>
+              <a:rPr sz="2200" b="0" i="0">
+                <a:solidFill>
+                  <a:srgbClr val="ECE7F0"/>
+                </a:solidFill>
+                <a:latin typeface="Iowan Old Style"/>
+              </a:rPr>
+              <a:t>Computational attention: word-to-word (or pixel), over and over</a:t>
+            </a:r>
+          </a:p>
+          <a:p>
+            <a:pPr marL="548640" indent="-219456">
+              <a:lnSpc>
+                <a:spcPct val="108000"/>
+              </a:lnSpc>
+              <a:spcAft>
+                <a:spcPts val="600"/>
+              </a:spcAft>
+              <a:buClr>
+                <a:srgbClr val="F0C9A0"/>
+              </a:buClr>
+              <a:buSzPct val="90000"/>
+              <a:buFont typeface="Arial"/>
+              <a:buChar char="–"/>
+            </a:pPr>
+            <a:r>
+              <a:rPr sz="2200" b="0" i="0">
+                <a:solidFill>
+                  <a:srgbClr val="ECE7F0"/>
+                </a:solidFill>
+                <a:latin typeface="Iowan Old Style"/>
+              </a:rPr>
+              <a:t>Human attention: layered through quite distinct processes (alert &gt; orient &gt; execute)</a:t>
+            </a:r>
+          </a:p>
+          <a:p>
+            <a:pPr marL="274320" indent="-219456">
+              <a:lnSpc>
+                <a:spcPct val="108000"/>
+              </a:lnSpc>
+              <a:spcAft>
+                <a:spcPts val="600"/>
+              </a:spcAft>
+              <a:buClr>
+                <a:srgbClr val="F0C9A0"/>
+              </a:buClr>
+              <a:buSzPct val="90000"/>
+              <a:buFont typeface="Arial"/>
+              <a:buChar char="•"/>
+            </a:pPr>
+            <a:r>
+              <a:rPr sz="2400" b="0" i="0">
+                <a:solidFill>
+                  <a:srgbClr val="ECE7F0"/>
+                </a:solidFill>
+                <a:latin typeface="Iowan Old Style"/>
+              </a:rPr>
+              <a:t>But in some sense can we also see some important similarities - especially when we compare textual interpretation (reading) / next token prediction (writing)?</a:t>
+            </a:r>
+          </a:p>
+        </p:txBody>
+      </p:sp>
       <p:sp>
         <p:nvSpPr>
           <p:cNvPr id="5" name="TextBox 4"/>
@@ -12882,7 +13040,7 @@
                 </a:solidFill>
                 <a:latin typeface="Iowan Old Style"/>
               </a:rPr>
-              <a:t>Attention and Imitation</a:t>
+              <a:t>Make Content, Get Attention… Profit?</a:t>
             </a:r>
           </a:p>
         </p:txBody>
@@ -12933,7 +13091,7 @@
       </p:sp>
       <p:pic>
         <p:nvPicPr>
-          <p:cNvPr id="4" name="Picture 3" descr="image.jpg"/>
+          <p:cNvPr id="4" name="Picture 3" descr="image.png"/>
           <p:cNvPicPr>
             <a:picLocks noChangeAspect="1"/>
           </p:cNvPicPr>
@@ -12947,8 +13105,8 @@
         </p:blipFill>
         <p:spPr>
           <a:xfrm>
-            <a:off x="3728200" y="1664207"/>
-            <a:ext cx="4735294" cy="4782312"/>
+            <a:off x="3704691" y="1664207"/>
+            <a:ext cx="4782312" cy="4782312"/>
           </a:xfrm>
           <a:prstGeom prst="rect">
             <a:avLst/>
@@ -13045,7 +13203,7 @@
                 </a:solidFill>
                 <a:latin typeface="Iowan Old Style"/>
               </a:rPr>
-              <a:t>Cooperation or Proletariatanization?</a:t>
+              <a:t>Attention and Imitation</a:t>
             </a:r>
           </a:p>
         </p:txBody>
@@ -13110,8 +13268,8 @@
         </p:blipFill>
         <p:spPr>
           <a:xfrm>
-            <a:off x="2031600" y="1664207"/>
-            <a:ext cx="8128494" cy="4782312"/>
+            <a:off x="3728200" y="1664207"/>
+            <a:ext cx="4735294" cy="4782312"/>
           </a:xfrm>
           <a:prstGeom prst="rect">
             <a:avLst/>
@@ -13208,7 +13366,7 @@
                 </a:solidFill>
                 <a:latin typeface="Iowan Old Style"/>
               </a:rPr>
-              <a:t>Is Attention a Design Problem?</a:t>
+              <a:t>Cooperation or Proletariatanization?</a:t>
             </a:r>
           </a:p>
         </p:txBody>
@@ -13273,8 +13431,8 @@
         </p:blipFill>
         <p:spPr>
           <a:xfrm>
-            <a:off x="1118179" y="1664207"/>
-            <a:ext cx="9955335" cy="4782312"/>
+            <a:off x="2031600" y="1664207"/>
+            <a:ext cx="8128494" cy="4782312"/>
           </a:xfrm>
           <a:prstGeom prst="rect">
             <a:avLst/>
@@ -13371,7 +13529,7 @@
                 </a:solidFill>
                 <a:latin typeface="Iowan Old Style"/>
               </a:rPr>
-              <a:t>Synthesizing Human and Machine Attention?</a:t>
+              <a:t>Is Attention a Design Problem?</a:t>
             </a:r>
           </a:p>
         </p:txBody>
@@ -13420,6 +13578,169 @@
           </a:p>
         </p:txBody>
       </p:sp>
+      <p:pic>
+        <p:nvPicPr>
+          <p:cNvPr id="4" name="Picture 3" descr="image.jpg"/>
+          <p:cNvPicPr>
+            <a:picLocks noChangeAspect="1"/>
+          </p:cNvPicPr>
+          <p:nvPr/>
+        </p:nvPicPr>
+        <p:blipFill>
+          <a:blip r:embed="rId2"/>
+          <a:stretch>
+            <a:fillRect/>
+          </a:stretch>
+        </p:blipFill>
+        <p:spPr>
+          <a:xfrm>
+            <a:off x="1118179" y="1664207"/>
+            <a:ext cx="9955335" cy="4782312"/>
+          </a:xfrm>
+          <a:prstGeom prst="rect">
+            <a:avLst/>
+          </a:prstGeom>
+        </p:spPr>
+      </p:pic>
+      <p:sp>
+        <p:nvSpPr>
+          <p:cNvPr id="5" name="TextBox 4"/>
+          <p:cNvSpPr txBox="1"/>
+          <p:nvPr/>
+        </p:nvSpPr>
+        <p:spPr>
+          <a:xfrm>
+            <a:off x="10664647" y="6446520"/>
+            <a:ext cx="914400" cy="274320"/>
+          </a:xfrm>
+          <a:prstGeom prst="rect">
+            <a:avLst/>
+          </a:prstGeom>
+          <a:noFill/>
+        </p:spPr>
+        <p:txBody>
+          <a:bodyPr wrap="square" anchor="t" lIns="0" rIns="0" tIns="0" bIns="0">
+            <a:noAutofit/>
+          </a:bodyPr>
+          <a:lstStyle/>
+          <a:p>
+            <a:pPr algn="r"/>
+            <a:r>
+              <a:rPr sz="1000" b="0" i="0">
+                <a:solidFill>
+                  <a:srgbClr val="A49DB8"/>
+                </a:solidFill>
+                <a:latin typeface="Iowan Old Style"/>
+              </a:rPr>
+              <a:t>37</a:t>
+            </a:r>
+          </a:p>
+        </p:txBody>
+      </p:sp>
+    </p:spTree>
+  </p:cSld>
+  <p:clrMapOvr>
+    <a:masterClrMapping/>
+  </p:clrMapOvr>
+</p:sld>
+</file>
+
+<file path=ppt/slides/slide38.xml><?xml version="1.0" encoding="utf-8"?>
+<p:sld xmlns:a="http://schemas.openxmlformats.org/drawingml/2006/main" xmlns:p="http://schemas.openxmlformats.org/presentationml/2006/main" xmlns:r="http://schemas.openxmlformats.org/officeDocument/2006/relationships">
+  <p:cSld>
+    <p:bg>
+      <p:bgPr>
+        <a:solidFill>
+          <a:srgbClr val="121021"/>
+        </a:solidFill>
+        <a:effectLst/>
+      </p:bgPr>
+    </p:bg>
+    <p:spTree>
+      <p:nvGrpSpPr>
+        <p:cNvPr id="1" name=""/>
+        <p:cNvGrpSpPr/>
+        <p:nvPr/>
+      </p:nvGrpSpPr>
+      <p:grpSpPr/>
+      <p:sp>
+        <p:nvSpPr>
+          <p:cNvPr id="2" name="TextBox 1"/>
+          <p:cNvSpPr txBox="1"/>
+          <p:nvPr/>
+        </p:nvSpPr>
+        <p:spPr>
+          <a:xfrm>
+            <a:off x="612648" y="457200"/>
+            <a:ext cx="10972800" cy="822960"/>
+          </a:xfrm>
+          <a:prstGeom prst="rect">
+            <a:avLst/>
+          </a:prstGeom>
+          <a:noFill/>
+        </p:spPr>
+        <p:txBody>
+          <a:bodyPr wrap="square" anchor="b" lIns="0" rIns="0" tIns="0" bIns="0">
+            <a:noAutofit/>
+          </a:bodyPr>
+          <a:lstStyle/>
+          <a:p>
+            <a:r>
+              <a:rPr sz="3300" b="0" i="0">
+                <a:solidFill>
+                  <a:srgbClr val="ECE7F0"/>
+                </a:solidFill>
+                <a:latin typeface="Iowan Old Style"/>
+              </a:rPr>
+              <a:t>Synthesizing Human and Machine Attention?</a:t>
+            </a:r>
+          </a:p>
+        </p:txBody>
+      </p:sp>
+      <p:sp>
+        <p:nvSpPr>
+          <p:cNvPr id="3" name="Rectangle 2"/>
+          <p:cNvSpPr/>
+          <p:nvPr/>
+        </p:nvSpPr>
+        <p:spPr>
+          <a:xfrm>
+            <a:off x="612648" y="1389888"/>
+            <a:ext cx="1097280" cy="32004"/>
+          </a:xfrm>
+          <a:prstGeom prst="rect">
+            <a:avLst/>
+          </a:prstGeom>
+          <a:solidFill>
+            <a:srgbClr val="F0C9A0"/>
+          </a:solidFill>
+          <a:ln>
+            <a:noFill/>
+          </a:ln>
+          <a:effectLst/>
+        </p:spPr>
+        <p:style>
+          <a:lnRef idx="1">
+            <a:schemeClr val="accent1"/>
+          </a:lnRef>
+          <a:fillRef idx="3">
+            <a:schemeClr val="accent1"/>
+          </a:fillRef>
+          <a:effectRef idx="2">
+            <a:schemeClr val="accent1"/>
+          </a:effectRef>
+          <a:fontRef idx="minor">
+            <a:schemeClr val="lt1"/>
+          </a:fontRef>
+        </p:style>
+        <p:txBody>
+          <a:bodyPr rtlCol="0" anchor="ctr"/>
+          <a:lstStyle/>
+          <a:p>
+            <a:pPr algn="ctr"/>
+          </a:p>
+        </p:txBody>
+      </p:sp>
       <p:sp>
         <p:nvSpPr>
           <p:cNvPr id="4" name="TextBox 3"/>
@@ -13569,7 +13890,237 @@
                 </a:solidFill>
                 <a:latin typeface="Iowan Old Style"/>
               </a:rPr>
-              <a:t>37</a:t>
+              <a:t>38</a:t>
+            </a:r>
+          </a:p>
+        </p:txBody>
+      </p:sp>
+    </p:spTree>
+  </p:cSld>
+  <p:clrMapOvr>
+    <a:masterClrMapping/>
+  </p:clrMapOvr>
+</p:sld>
+</file>
+
+<file path=ppt/slides/slide39.xml><?xml version="1.0" encoding="utf-8"?>
+<p:sld xmlns:a="http://schemas.openxmlformats.org/drawingml/2006/main" xmlns:p="http://schemas.openxmlformats.org/presentationml/2006/main" xmlns:r="http://schemas.openxmlformats.org/officeDocument/2006/relationships">
+  <p:cSld>
+    <p:bg>
+      <p:bgPr>
+        <a:solidFill>
+          <a:srgbClr val="121021"/>
+        </a:solidFill>
+        <a:effectLst/>
+      </p:bgPr>
+    </p:bg>
+    <p:spTree>
+      <p:nvGrpSpPr>
+        <p:cNvPr id="1" name=""/>
+        <p:cNvGrpSpPr/>
+        <p:nvPr/>
+      </p:nvGrpSpPr>
+      <p:grpSpPr/>
+      <p:sp>
+        <p:nvSpPr>
+          <p:cNvPr id="2" name="TextBox 1"/>
+          <p:cNvSpPr txBox="1"/>
+          <p:nvPr/>
+        </p:nvSpPr>
+        <p:spPr>
+          <a:xfrm>
+            <a:off x="612648" y="457200"/>
+            <a:ext cx="10972800" cy="1097280"/>
+          </a:xfrm>
+          <a:prstGeom prst="rect">
+            <a:avLst/>
+          </a:prstGeom>
+          <a:noFill/>
+        </p:spPr>
+        <p:txBody>
+          <a:bodyPr wrap="square" anchor="b" lIns="0" rIns="0" tIns="0" bIns="0">
+            <a:noAutofit/>
+          </a:bodyPr>
+          <a:lstStyle/>
+          <a:p>
+            <a:r>
+              <a:rPr sz="3300" b="0" i="0">
+                <a:solidFill>
+                  <a:srgbClr val="ECE7F0"/>
+                </a:solidFill>
+                <a:latin typeface="Iowan Old Style"/>
+              </a:rPr>
+              <a:t>From Absolute Spirit to the General Intellect and Social Mind (Terranova, Hansen)</a:t>
+            </a:r>
+          </a:p>
+        </p:txBody>
+      </p:sp>
+      <p:sp>
+        <p:nvSpPr>
+          <p:cNvPr id="3" name="Rectangle 2"/>
+          <p:cNvSpPr/>
+          <p:nvPr/>
+        </p:nvSpPr>
+        <p:spPr>
+          <a:xfrm>
+            <a:off x="612648" y="1664208"/>
+            <a:ext cx="1097280" cy="32004"/>
+          </a:xfrm>
+          <a:prstGeom prst="rect">
+            <a:avLst/>
+          </a:prstGeom>
+          <a:solidFill>
+            <a:srgbClr val="F0C9A0"/>
+          </a:solidFill>
+          <a:ln>
+            <a:noFill/>
+          </a:ln>
+          <a:effectLst/>
+        </p:spPr>
+        <p:style>
+          <a:lnRef idx="1">
+            <a:schemeClr val="accent1"/>
+          </a:lnRef>
+          <a:fillRef idx="3">
+            <a:schemeClr val="accent1"/>
+          </a:fillRef>
+          <a:effectRef idx="2">
+            <a:schemeClr val="accent1"/>
+          </a:effectRef>
+          <a:fontRef idx="minor">
+            <a:schemeClr val="lt1"/>
+          </a:fontRef>
+        </p:style>
+        <p:txBody>
+          <a:bodyPr rtlCol="0" anchor="ctr"/>
+          <a:lstStyle/>
+          <a:p>
+            <a:pPr algn="ctr"/>
+          </a:p>
+        </p:txBody>
+      </p:sp>
+      <p:sp>
+        <p:nvSpPr>
+          <p:cNvPr id="4" name="TextBox 3"/>
+          <p:cNvSpPr txBox="1"/>
+          <p:nvPr/>
+        </p:nvSpPr>
+        <p:spPr>
+          <a:xfrm>
+            <a:off x="612648" y="1938528"/>
+            <a:ext cx="10972800" cy="1249679"/>
+          </a:xfrm>
+          <a:prstGeom prst="rect">
+            <a:avLst/>
+          </a:prstGeom>
+          <a:noFill/>
+        </p:spPr>
+        <p:txBody>
+          <a:bodyPr wrap="square" anchor="t" lIns="0" rIns="0" tIns="0" bIns="0">
+            <a:noAutofit/>
+          </a:bodyPr>
+          <a:lstStyle/>
+          <a:p>
+            <a:pPr marL="274320" indent="-219456">
+              <a:lnSpc>
+                <a:spcPct val="108000"/>
+              </a:lnSpc>
+              <a:spcAft>
+                <a:spcPts val="600"/>
+              </a:spcAft>
+              <a:buClr>
+                <a:srgbClr val="F0C9A0"/>
+              </a:buClr>
+              <a:buSzPct val="90000"/>
+              <a:buFont typeface="Arial"/>
+              <a:buChar char="•"/>
+            </a:pPr>
+            <a:r>
+              <a:rPr sz="2400" b="0" i="0">
+                <a:solidFill>
+                  <a:srgbClr val="ECE7F0"/>
+                </a:solidFill>
+                <a:latin typeface="Iowan Old Style"/>
+              </a:rPr>
+              <a:t>One view of machine learning: it is a </a:t>
+            </a:r>
+            <a:r>
+              <a:rPr sz="2400" b="0" i="1">
+                <a:solidFill>
+                  <a:srgbClr val="ECE7F0"/>
+                </a:solidFill>
+                <a:latin typeface="Iowan Old Style"/>
+              </a:rPr>
+              <a:t>social</a:t>
+            </a:r>
+            <a:r>
+              <a:rPr sz="2400" b="0" i="0">
+                <a:solidFill>
+                  <a:srgbClr val="ECE7F0"/>
+                </a:solidFill>
+                <a:latin typeface="Iowan Old Style"/>
+              </a:rPr>
+              <a:t> product that helps us realize a collective intellectual potential</a:t>
+            </a:r>
+          </a:p>
+          <a:p>
+            <a:pPr marL="274320" indent="-219456">
+              <a:lnSpc>
+                <a:spcPct val="108000"/>
+              </a:lnSpc>
+              <a:spcAft>
+                <a:spcPts val="600"/>
+              </a:spcAft>
+              <a:buClr>
+                <a:srgbClr val="F0C9A0"/>
+              </a:buClr>
+              <a:buSzPct val="90000"/>
+              <a:buFont typeface="Arial"/>
+              <a:buChar char="•"/>
+            </a:pPr>
+            <a:r>
+              <a:rPr sz="2400" b="0" i="0">
+                <a:solidFill>
+                  <a:srgbClr val="ECE7F0"/>
+                </a:solidFill>
+                <a:latin typeface="Iowan Old Style"/>
+              </a:rPr>
+              <a:t>Return to this in Week 7.</a:t>
+            </a:r>
+          </a:p>
+        </p:txBody>
+      </p:sp>
+      <p:sp>
+        <p:nvSpPr>
+          <p:cNvPr id="5" name="TextBox 4"/>
+          <p:cNvSpPr txBox="1"/>
+          <p:nvPr/>
+        </p:nvSpPr>
+        <p:spPr>
+          <a:xfrm>
+            <a:off x="10664647" y="6446520"/>
+            <a:ext cx="914400" cy="274320"/>
+          </a:xfrm>
+          <a:prstGeom prst="rect">
+            <a:avLst/>
+          </a:prstGeom>
+          <a:noFill/>
+        </p:spPr>
+        <p:txBody>
+          <a:bodyPr wrap="square" anchor="t" lIns="0" rIns="0" tIns="0" bIns="0">
+            <a:noAutofit/>
+          </a:bodyPr>
+          <a:lstStyle/>
+          <a:p>
+            <a:pPr algn="r"/>
+            <a:r>
+              <a:rPr sz="1000" b="0" i="0">
+                <a:solidFill>
+                  <a:srgbClr val="A49DB8"/>
+                </a:solidFill>
+                <a:latin typeface="Iowan Old Style"/>
+              </a:rPr>
+              <a:t>39</a:t>
             </a:r>
           </a:p>
         </p:txBody>
@@ -13687,7 +14238,7 @@
         <p:spPr>
           <a:xfrm>
             <a:off x="612648" y="1664207"/>
-            <a:ext cx="10972800" cy="883919"/>
+            <a:ext cx="10972800" cy="1615440"/>
           </a:xfrm>
           <a:prstGeom prst="rect">
             <a:avLst/>
@@ -13746,7 +14297,43 @@
                 </a:solidFill>
                 <a:latin typeface="Iowan Old Style"/>
               </a:rPr>
-              <a:t>Peer review: TBD</a:t>
+              <a:t>Peer review: Weeks 5 &amp; 7 - bring your definitions of </a:t>
+            </a:r>
+            <a:r>
+              <a:rPr sz="2400" b="1" i="0">
+                <a:solidFill>
+                  <a:srgbClr val="ECE7F0"/>
+                </a:solidFill>
+                <a:latin typeface="Iowan Old Style"/>
+              </a:rPr>
+              <a:t>human and machine learning</a:t>
+            </a:r>
+            <a:r>
+              <a:rPr sz="2400" b="0" i="0">
+                <a:solidFill>
+                  <a:srgbClr val="ECE7F0"/>
+                </a:solidFill>
+                <a:latin typeface="Iowan Old Style"/>
+              </a:rPr>
+              <a:t> and </a:t>
+            </a:r>
+            <a:r>
+              <a:rPr sz="2400" b="1" i="0">
+                <a:solidFill>
+                  <a:srgbClr val="ECE7F0"/>
+                </a:solidFill>
+                <a:latin typeface="Iowan Old Style"/>
+              </a:rPr>
+              <a:t>key question</a:t>
+            </a:r>
+            <a:r>
+              <a:rPr sz="2400" b="0" i="0">
+                <a:solidFill>
+                  <a:srgbClr val="ECE7F0"/>
+                </a:solidFill>
+                <a:latin typeface="Iowan Old Style"/>
+              </a:rPr>
+              <a:t> to class. We’ll use these in the break-out discussions.</a:t>
             </a:r>
           </a:p>
         </p:txBody>
@@ -13782,6 +14369,243 @@
                 <a:latin typeface="Iowan Old Style"/>
               </a:rPr>
               <a:t>4</a:t>
+            </a:r>
+          </a:p>
+        </p:txBody>
+      </p:sp>
+    </p:spTree>
+  </p:cSld>
+  <p:clrMapOvr>
+    <a:masterClrMapping/>
+  </p:clrMapOvr>
+</p:sld>
+</file>
+
+<file path=ppt/slides/slide40.xml><?xml version="1.0" encoding="utf-8"?>
+<p:sld xmlns:a="http://schemas.openxmlformats.org/drawingml/2006/main" xmlns:p="http://schemas.openxmlformats.org/presentationml/2006/main" xmlns:r="http://schemas.openxmlformats.org/officeDocument/2006/relationships">
+  <p:cSld>
+    <p:bg>
+      <p:bgPr>
+        <a:solidFill>
+          <a:srgbClr val="121021"/>
+        </a:solidFill>
+        <a:effectLst/>
+      </p:bgPr>
+    </p:bg>
+    <p:spTree>
+      <p:nvGrpSpPr>
+        <p:cNvPr id="1" name=""/>
+        <p:cNvGrpSpPr/>
+        <p:nvPr/>
+      </p:nvGrpSpPr>
+      <p:grpSpPr/>
+      <p:sp>
+        <p:nvSpPr>
+          <p:cNvPr id="2" name="TextBox 1"/>
+          <p:cNvSpPr txBox="1"/>
+          <p:nvPr/>
+        </p:nvSpPr>
+        <p:spPr>
+          <a:xfrm>
+            <a:off x="612648" y="457200"/>
+            <a:ext cx="10972800" cy="822960"/>
+          </a:xfrm>
+          <a:prstGeom prst="rect">
+            <a:avLst/>
+          </a:prstGeom>
+          <a:noFill/>
+        </p:spPr>
+        <p:txBody>
+          <a:bodyPr wrap="square" anchor="b" lIns="0" rIns="0" tIns="0" bIns="0">
+            <a:noAutofit/>
+          </a:bodyPr>
+          <a:lstStyle/>
+          <a:p>
+            <a:r>
+              <a:rPr sz="3300" b="0" i="0">
+                <a:solidFill>
+                  <a:srgbClr val="ECE7F0"/>
+                </a:solidFill>
+                <a:latin typeface="Iowan Old Style"/>
+              </a:rPr>
+              <a:t>Break-out Rooms</a:t>
+            </a:r>
+          </a:p>
+        </p:txBody>
+      </p:sp>
+      <p:sp>
+        <p:nvSpPr>
+          <p:cNvPr id="3" name="Rectangle 2"/>
+          <p:cNvSpPr/>
+          <p:nvPr/>
+        </p:nvSpPr>
+        <p:spPr>
+          <a:xfrm>
+            <a:off x="612648" y="1389888"/>
+            <a:ext cx="1097280" cy="32004"/>
+          </a:xfrm>
+          <a:prstGeom prst="rect">
+            <a:avLst/>
+          </a:prstGeom>
+          <a:solidFill>
+            <a:srgbClr val="F0C9A0"/>
+          </a:solidFill>
+          <a:ln>
+            <a:noFill/>
+          </a:ln>
+          <a:effectLst/>
+        </p:spPr>
+        <p:style>
+          <a:lnRef idx="1">
+            <a:schemeClr val="accent1"/>
+          </a:lnRef>
+          <a:fillRef idx="3">
+            <a:schemeClr val="accent1"/>
+          </a:fillRef>
+          <a:effectRef idx="2">
+            <a:schemeClr val="accent1"/>
+          </a:effectRef>
+          <a:fontRef idx="minor">
+            <a:schemeClr val="lt1"/>
+          </a:fontRef>
+        </p:style>
+        <p:txBody>
+          <a:bodyPr rtlCol="0" anchor="ctr"/>
+          <a:lstStyle/>
+          <a:p>
+            <a:pPr algn="ctr"/>
+          </a:p>
+        </p:txBody>
+      </p:sp>
+      <p:sp>
+        <p:nvSpPr>
+          <p:cNvPr id="4" name="TextBox 3"/>
+          <p:cNvSpPr txBox="1"/>
+          <p:nvPr/>
+        </p:nvSpPr>
+        <p:spPr>
+          <a:xfrm>
+            <a:off x="612648" y="1664207"/>
+            <a:ext cx="10972800" cy="2788920"/>
+          </a:xfrm>
+          <a:prstGeom prst="rect">
+            <a:avLst/>
+          </a:prstGeom>
+          <a:noFill/>
+        </p:spPr>
+        <p:txBody>
+          <a:bodyPr wrap="square" anchor="t" lIns="0" rIns="0" tIns="0" bIns="0">
+            <a:noAutofit/>
+          </a:bodyPr>
+          <a:lstStyle/>
+          <a:p>
+            <a:pPr marL="274320" indent="-219456">
+              <a:lnSpc>
+                <a:spcPct val="108000"/>
+              </a:lnSpc>
+              <a:spcAft>
+                <a:spcPts val="600"/>
+              </a:spcAft>
+              <a:buClr>
+                <a:srgbClr val="F0C9A0"/>
+              </a:buClr>
+              <a:buSzPct val="90000"/>
+              <a:buFont typeface="Arial"/>
+              <a:buChar char="•"/>
+            </a:pPr>
+            <a:r>
+              <a:rPr sz="2400" b="0" i="0">
+                <a:solidFill>
+                  <a:srgbClr val="ECE7F0"/>
+                </a:solidFill>
+                <a:latin typeface="Iowan Old Style"/>
+              </a:rPr>
+              <a:t>How useful is the concept of attention in understanding similarities and differences between machine and human learning?</a:t>
+            </a:r>
+          </a:p>
+          <a:p>
+            <a:pPr marL="274320" indent="-219456">
+              <a:lnSpc>
+                <a:spcPct val="108000"/>
+              </a:lnSpc>
+              <a:spcAft>
+                <a:spcPts val="600"/>
+              </a:spcAft>
+              <a:buClr>
+                <a:srgbClr val="F0C9A0"/>
+              </a:buClr>
+              <a:buSzPct val="90000"/>
+              <a:buFont typeface="Arial"/>
+              <a:buChar char="•"/>
+            </a:pPr>
+            <a:r>
+              <a:rPr sz="2400" b="0" i="0">
+                <a:solidFill>
+                  <a:srgbClr val="ECE7F0"/>
+                </a:solidFill>
+                <a:latin typeface="Iowan Old Style"/>
+              </a:rPr>
+              <a:t>How might the machinic concept of attention limit its ability to learn? What about human attention - is this mechanism a limitation to learning, especially in the digital age?</a:t>
+            </a:r>
+          </a:p>
+          <a:p>
+            <a:pPr marL="274320" indent="-219456">
+              <a:lnSpc>
+                <a:spcPct val="108000"/>
+              </a:lnSpc>
+              <a:spcAft>
+                <a:spcPts val="600"/>
+              </a:spcAft>
+              <a:buClr>
+                <a:srgbClr val="F0C9A0"/>
+              </a:buClr>
+              <a:buSzPct val="90000"/>
+              <a:buFont typeface="Arial"/>
+              <a:buChar char="•"/>
+            </a:pPr>
+            <a:r>
+              <a:rPr sz="2400" b="0" i="0">
+                <a:solidFill>
+                  <a:srgbClr val="ECE7F0"/>
+                </a:solidFill>
+                <a:latin typeface="Iowan Old Style"/>
+              </a:rPr>
+              <a:t>Terranova and Hansen present critical views on how attention is monetized and controlled. But are there positive sides to this?</a:t>
+            </a:r>
+          </a:p>
+        </p:txBody>
+      </p:sp>
+      <p:sp>
+        <p:nvSpPr>
+          <p:cNvPr id="5" name="TextBox 4"/>
+          <p:cNvSpPr txBox="1"/>
+          <p:nvPr/>
+        </p:nvSpPr>
+        <p:spPr>
+          <a:xfrm>
+            <a:off x="10664647" y="6446520"/>
+            <a:ext cx="914400" cy="274320"/>
+          </a:xfrm>
+          <a:prstGeom prst="rect">
+            <a:avLst/>
+          </a:prstGeom>
+          <a:noFill/>
+        </p:spPr>
+        <p:txBody>
+          <a:bodyPr wrap="square" anchor="t" lIns="0" rIns="0" tIns="0" bIns="0">
+            <a:noAutofit/>
+          </a:bodyPr>
+          <a:lstStyle/>
+          <a:p>
+            <a:pPr algn="r"/>
+            <a:r>
+              <a:rPr sz="1000" b="0" i="0">
+                <a:solidFill>
+                  <a:srgbClr val="A49DB8"/>
+                </a:solidFill>
+                <a:latin typeface="Iowan Old Style"/>
+              </a:rPr>
+              <a:t>40</a:t>
             </a:r>
           </a:p>
         </p:txBody>
@@ -13899,7 +14723,7 @@
         <p:spPr>
           <a:xfrm>
             <a:off x="612648" y="1664207"/>
-            <a:ext cx="10972800" cy="2788920"/>
+            <a:ext cx="10972800" cy="3596640"/>
           </a:xfrm>
           <a:prstGeom prst="rect">
             <a:avLst/>
@@ -14095,6 +14919,31 @@
                 <a:latin typeface="Iowan Old Style"/>
               </a:rPr>
               <a:t>, 13.</a:t>
+            </a:r>
+          </a:p>
+          <a:p>
+            <a:pPr marL="274320" indent="-219456">
+              <a:lnSpc>
+                <a:spcPct val="108000"/>
+              </a:lnSpc>
+              <a:spcAft>
+                <a:spcPts val="600"/>
+              </a:spcAft>
+              <a:buClr>
+                <a:srgbClr val="F0C9A0"/>
+              </a:buClr>
+              <a:buSzPct val="90000"/>
+              <a:buFont typeface="Arial"/>
+              <a:buChar char="•"/>
+            </a:pPr>
+            <a:r>
+              <a:rPr sz="2400" b="0" i="0">
+                <a:solidFill>
+                  <a:srgbClr val="ECE7F0"/>
+                </a:solidFill>
+                <a:latin typeface="Iowan Old Style"/>
+              </a:rPr>
+              <a:t>Hansen, M. (2024). From attention economy to cognitive lock-ins. Big Data &amp; Society, 11(3), 20539517241275878.</a:t>
             </a:r>
           </a:p>
         </p:txBody>

</xml_diff>